<commit_message>
20260909 SICU nursine course
</commit_message>
<xml_diff>
--- a/icu_medication_safety_presentation.pptx
+++ b/icu_medication_safety_presentation.pptx
@@ -4038,7 +4038,7 @@
                   <a:srgbClr val="0284C7"/>
                 </a:solidFill>
               </a:rPr>
-              <a:t>【藥物安全流程】給藥 → 監測 → 發現變化 → 確認可能藥物 → 回報與處理</a:t>
+              <a:t>【五階段閉環流程】精準給藥 → 主動監測 → 察覺變化 → 回推藥物 → 即時處置（ISBAR 通報・停藥急救）</a:t>
             </a:r>
           </a:p>
           <a:p>
@@ -4049,7 +4049,7 @@
                   <a:srgbClr val="0284C7"/>
                 </a:solidFill>
               </a:rPr>
-              <a:t>【床邊 8 大常見警訊】</a:t>
+              <a:t>【床邊 8 大常見潛在藥物警訊】</a:t>
             </a:r>
           </a:p>
           <a:p>
@@ -4060,7 +4060,7 @@
                   <a:srgbClr val="1E293B"/>
                 </a:solidFill>
               </a:rPr>
-              <a:t>• 血壓突然下降    • 心率明顯過快或過慢    • 尿量下降    • 意識或呼吸改變</a:t>
+              <a:t>• 1. 血壓突然劇降    • 2. 心率過快或過慢    • 3. 尿量持續下降    • 4. 意識或呼吸抑制</a:t>
             </a:r>
           </a:p>
           <a:p>
@@ -4071,7 +4071,7 @@
                   <a:srgbClr val="1E293B"/>
                 </a:solidFill>
               </a:rPr>
-              <a:t>• QTc延長        • 血小板快速下降        • 不明原因出血 • 新發紅疹或黏膜病灶</a:t>
+              <a:t>• 5. QTc 間期延長    • 6. 血小板急速驟降    • 7. 不明原因出血    • 8. 新發紅疹或黏膜潰爛</a:t>
             </a:r>
           </a:p>
           <a:p>
@@ -4082,7 +4082,7 @@
                   <a:srgbClr val="0284C7"/>
                 </a:solidFill>
               </a:rPr>
-              <a:t>【核心訊息】護理人員往往是最早發現藥物不良反應的人！</a:t>
+              <a:t>【核心防線】護理人員往往是全醫療團隊中「最早發現藥物不良反應的人」！</a:t>
             </a:r>
           </a:p>
         </p:txBody>

</xml_diff>